<commit_message>
Enhance: Add Forgot Password flow and Contact Admin support system
</commit_message>
<xml_diff>
--- a/Smart_Alumni_Mentoring_System.pptx
+++ b/Smart_Alumni_Mentoring_System.pptx
@@ -5,20 +5,20 @@
     <p:sldMasterId id="2147483648" r:id="rId1"/>
   </p:sldMasterIdLst>
   <p:sldIdLst>
-    <p:sldId id="256" r:id="rId7"/>
-    <p:sldId id="257" r:id="rId8"/>
-    <p:sldId id="258" r:id="rId9"/>
-    <p:sldId id="259" r:id="rId10"/>
-    <p:sldId id="260" r:id="rId11"/>
-    <p:sldId id="261" r:id="rId12"/>
-    <p:sldId id="262" r:id="rId13"/>
-    <p:sldId id="263" r:id="rId14"/>
-    <p:sldId id="264" r:id="rId15"/>
-    <p:sldId id="265" r:id="rId16"/>
-    <p:sldId id="266" r:id="rId17"/>
-    <p:sldId id="267" r:id="rId18"/>
-    <p:sldId id="268" r:id="rId19"/>
-    <p:sldId id="269" r:id="rId20"/>
+    <p:sldId id="256" r:id="rId2"/>
+    <p:sldId id="257" r:id="rId3"/>
+    <p:sldId id="258" r:id="rId4"/>
+    <p:sldId id="259" r:id="rId5"/>
+    <p:sldId id="260" r:id="rId6"/>
+    <p:sldId id="261" r:id="rId7"/>
+    <p:sldId id="262" r:id="rId8"/>
+    <p:sldId id="263" r:id="rId9"/>
+    <p:sldId id="264" r:id="rId10"/>
+    <p:sldId id="265" r:id="rId11"/>
+    <p:sldId id="266" r:id="rId12"/>
+    <p:sldId id="267" r:id="rId13"/>
+    <p:sldId id="268" r:id="rId14"/>
+    <p:sldId id="269" r:id="rId15"/>
   </p:sldIdLst>
   <p:sldSz cx="9144000" cy="6858000" type="screen4x3"/>
   <p:notesSz cx="6858000" cy="9144000"/>
@@ -117,6 +117,22 @@
       </a:defRPr>
     </a:lvl9pPr>
   </p:defaultTextStyle>
+  <p:extLst>
+    <p:ext uri="{EFAFB233-063F-42B5-8137-9DF3F51BA10A}">
+      <p15:sldGuideLst xmlns:p15="http://schemas.microsoft.com/office/powerpoint/2012/main">
+        <p15:guide id="1" orient="horz" pos="2160">
+          <p15:clr>
+            <a:srgbClr val="A4A3A4"/>
+          </p15:clr>
+        </p15:guide>
+        <p15:guide id="2" pos="2880">
+          <p15:clr>
+            <a:srgbClr val="A4A3A4"/>
+          </p15:clr>
+        </p15:guide>
+      </p15:sldGuideLst>
+    </p:ext>
+  </p:extLst>
 </p:presentation>
 </file>
 
@@ -158,10 +174,9 @@
           <a:lstStyle/>
           <a:p>
             <a:r>
-              <a:rPr lang="en-US" smtClean="0"/>
+              <a:rPr lang="en-US"/>
               <a:t>Click to edit Master title style</a:t>
             </a:r>
-            <a:endParaRPr lang="en-US"/>
           </a:p>
         </p:txBody>
       </p:sp>
@@ -277,10 +292,9 @@
           </a:lstStyle>
           <a:p>
             <a:r>
-              <a:rPr lang="en-US" smtClean="0"/>
+              <a:rPr lang="en-US"/>
               <a:t>Click to edit Master subtitle style</a:t>
             </a:r>
-            <a:endParaRPr lang="en-US"/>
           </a:p>
         </p:txBody>
       </p:sp>
@@ -301,7 +315,7 @@
           <a:p>
             <a:fld id="{5BCAD085-E8A6-8845-BD4E-CB4CCA059FC4}" type="datetimeFigureOut">
               <a:rPr lang="en-US" smtClean="0"/>
-              <a:t>1/27/13</a:t>
+              <a:t>4/30/2026</a:t>
             </a:fld>
             <a:endParaRPr lang="en-US"/>
           </a:p>
@@ -395,10 +409,9 @@
           <a:lstStyle/>
           <a:p>
             <a:r>
-              <a:rPr lang="en-US" smtClean="0"/>
+              <a:rPr lang="en-US"/>
               <a:t>Click to edit Master title style</a:t>
             </a:r>
-            <a:endParaRPr lang="en-US"/>
           </a:p>
         </p:txBody>
       </p:sp>
@@ -419,38 +432,37 @@
           <a:p>
             <a:pPr lvl="0"/>
             <a:r>
-              <a:rPr lang="en-US" smtClean="0"/>
+              <a:rPr lang="en-US"/>
               <a:t>Click to edit Master text styles</a:t>
             </a:r>
           </a:p>
           <a:p>
             <a:pPr lvl="1"/>
             <a:r>
-              <a:rPr lang="en-US" smtClean="0"/>
+              <a:rPr lang="en-US"/>
               <a:t>Second level</a:t>
             </a:r>
           </a:p>
           <a:p>
             <a:pPr lvl="2"/>
             <a:r>
-              <a:rPr lang="en-US" smtClean="0"/>
+              <a:rPr lang="en-US"/>
               <a:t>Third level</a:t>
             </a:r>
           </a:p>
           <a:p>
             <a:pPr lvl="3"/>
             <a:r>
-              <a:rPr lang="en-US" smtClean="0"/>
+              <a:rPr lang="en-US"/>
               <a:t>Fourth level</a:t>
             </a:r>
           </a:p>
           <a:p>
             <a:pPr lvl="4"/>
             <a:r>
-              <a:rPr lang="en-US" smtClean="0"/>
+              <a:rPr lang="en-US"/>
               <a:t>Fifth level</a:t>
             </a:r>
-            <a:endParaRPr lang="en-US"/>
           </a:p>
         </p:txBody>
       </p:sp>
@@ -471,7 +483,7 @@
           <a:p>
             <a:fld id="{5BCAD085-E8A6-8845-BD4E-CB4CCA059FC4}" type="datetimeFigureOut">
               <a:rPr lang="en-US" smtClean="0"/>
-              <a:t>1/27/13</a:t>
+              <a:t>4/30/2026</a:t>
             </a:fld>
             <a:endParaRPr lang="en-US"/>
           </a:p>
@@ -570,10 +582,9 @@
           <a:lstStyle/>
           <a:p>
             <a:r>
-              <a:rPr lang="en-US" smtClean="0"/>
+              <a:rPr lang="en-US"/>
               <a:t>Click to edit Master title style</a:t>
             </a:r>
-            <a:endParaRPr lang="en-US"/>
           </a:p>
         </p:txBody>
       </p:sp>
@@ -599,38 +610,37 @@
           <a:p>
             <a:pPr lvl="0"/>
             <a:r>
-              <a:rPr lang="en-US" smtClean="0"/>
+              <a:rPr lang="en-US"/>
               <a:t>Click to edit Master text styles</a:t>
             </a:r>
           </a:p>
           <a:p>
             <a:pPr lvl="1"/>
             <a:r>
-              <a:rPr lang="en-US" smtClean="0"/>
+              <a:rPr lang="en-US"/>
               <a:t>Second level</a:t>
             </a:r>
           </a:p>
           <a:p>
             <a:pPr lvl="2"/>
             <a:r>
-              <a:rPr lang="en-US" smtClean="0"/>
+              <a:rPr lang="en-US"/>
               <a:t>Third level</a:t>
             </a:r>
           </a:p>
           <a:p>
             <a:pPr lvl="3"/>
             <a:r>
-              <a:rPr lang="en-US" smtClean="0"/>
+              <a:rPr lang="en-US"/>
               <a:t>Fourth level</a:t>
             </a:r>
           </a:p>
           <a:p>
             <a:pPr lvl="4"/>
             <a:r>
-              <a:rPr lang="en-US" smtClean="0"/>
+              <a:rPr lang="en-US"/>
               <a:t>Fifth level</a:t>
             </a:r>
-            <a:endParaRPr lang="en-US"/>
           </a:p>
         </p:txBody>
       </p:sp>
@@ -651,7 +661,7 @@
           <a:p>
             <a:fld id="{5BCAD085-E8A6-8845-BD4E-CB4CCA059FC4}" type="datetimeFigureOut">
               <a:rPr lang="en-US" smtClean="0"/>
-              <a:t>1/27/13</a:t>
+              <a:t>4/30/2026</a:t>
             </a:fld>
             <a:endParaRPr lang="en-US"/>
           </a:p>
@@ -745,10 +755,9 @@
           <a:lstStyle/>
           <a:p>
             <a:r>
-              <a:rPr lang="en-US" smtClean="0"/>
+              <a:rPr lang="en-US"/>
               <a:t>Click to edit Master title style</a:t>
             </a:r>
-            <a:endParaRPr lang="en-US"/>
           </a:p>
         </p:txBody>
       </p:sp>
@@ -769,38 +778,37 @@
           <a:p>
             <a:pPr lvl="0"/>
             <a:r>
-              <a:rPr lang="en-US" smtClean="0"/>
+              <a:rPr lang="en-US"/>
               <a:t>Click to edit Master text styles</a:t>
             </a:r>
           </a:p>
           <a:p>
             <a:pPr lvl="1"/>
             <a:r>
-              <a:rPr lang="en-US" smtClean="0"/>
+              <a:rPr lang="en-US"/>
               <a:t>Second level</a:t>
             </a:r>
           </a:p>
           <a:p>
             <a:pPr lvl="2"/>
             <a:r>
-              <a:rPr lang="en-US" smtClean="0"/>
+              <a:rPr lang="en-US"/>
               <a:t>Third level</a:t>
             </a:r>
           </a:p>
           <a:p>
             <a:pPr lvl="3"/>
             <a:r>
-              <a:rPr lang="en-US" smtClean="0"/>
+              <a:rPr lang="en-US"/>
               <a:t>Fourth level</a:t>
             </a:r>
           </a:p>
           <a:p>
             <a:pPr lvl="4"/>
             <a:r>
-              <a:rPr lang="en-US" smtClean="0"/>
+              <a:rPr lang="en-US"/>
               <a:t>Fifth level</a:t>
             </a:r>
-            <a:endParaRPr lang="en-US"/>
           </a:p>
         </p:txBody>
       </p:sp>
@@ -821,7 +829,7 @@
           <a:p>
             <a:fld id="{5BCAD085-E8A6-8845-BD4E-CB4CCA059FC4}" type="datetimeFigureOut">
               <a:rPr lang="en-US" smtClean="0"/>
-              <a:t>1/27/13</a:t>
+              <a:t>4/30/2026</a:t>
             </a:fld>
             <a:endParaRPr lang="en-US"/>
           </a:p>
@@ -924,10 +932,9 @@
           </a:lstStyle>
           <a:p>
             <a:r>
-              <a:rPr lang="en-US" smtClean="0"/>
+              <a:rPr lang="en-US"/>
               <a:t>Click to edit Master title style</a:t>
             </a:r>
-            <a:endParaRPr lang="en-US"/>
           </a:p>
         </p:txBody>
       </p:sp>
@@ -1044,7 +1051,7 @@
           <a:p>
             <a:pPr lvl="0"/>
             <a:r>
-              <a:rPr lang="en-US" smtClean="0"/>
+              <a:rPr lang="en-US"/>
               <a:t>Click to edit Master text styles</a:t>
             </a:r>
           </a:p>
@@ -1067,7 +1074,7 @@
           <a:p>
             <a:fld id="{5BCAD085-E8A6-8845-BD4E-CB4CCA059FC4}" type="datetimeFigureOut">
               <a:rPr lang="en-US" smtClean="0"/>
-              <a:t>1/27/13</a:t>
+              <a:t>4/30/2026</a:t>
             </a:fld>
             <a:endParaRPr lang="en-US"/>
           </a:p>
@@ -1161,10 +1168,9 @@
           <a:lstStyle/>
           <a:p>
             <a:r>
-              <a:rPr lang="en-US" smtClean="0"/>
+              <a:rPr lang="en-US"/>
               <a:t>Click to edit Master title style</a:t>
             </a:r>
-            <a:endParaRPr lang="en-US"/>
           </a:p>
         </p:txBody>
       </p:sp>
@@ -1218,38 +1224,37 @@
           <a:p>
             <a:pPr lvl="0"/>
             <a:r>
-              <a:rPr lang="en-US" smtClean="0"/>
+              <a:rPr lang="en-US"/>
               <a:t>Click to edit Master text styles</a:t>
             </a:r>
           </a:p>
           <a:p>
             <a:pPr lvl="1"/>
             <a:r>
-              <a:rPr lang="en-US" smtClean="0"/>
+              <a:rPr lang="en-US"/>
               <a:t>Second level</a:t>
             </a:r>
           </a:p>
           <a:p>
             <a:pPr lvl="2"/>
             <a:r>
-              <a:rPr lang="en-US" smtClean="0"/>
+              <a:rPr lang="en-US"/>
               <a:t>Third level</a:t>
             </a:r>
           </a:p>
           <a:p>
             <a:pPr lvl="3"/>
             <a:r>
-              <a:rPr lang="en-US" smtClean="0"/>
+              <a:rPr lang="en-US"/>
               <a:t>Fourth level</a:t>
             </a:r>
           </a:p>
           <a:p>
             <a:pPr lvl="4"/>
             <a:r>
-              <a:rPr lang="en-US" smtClean="0"/>
+              <a:rPr lang="en-US"/>
               <a:t>Fifth level</a:t>
             </a:r>
-            <a:endParaRPr lang="en-US"/>
           </a:p>
         </p:txBody>
       </p:sp>
@@ -1303,38 +1308,37 @@
           <a:p>
             <a:pPr lvl="0"/>
             <a:r>
-              <a:rPr lang="en-US" smtClean="0"/>
+              <a:rPr lang="en-US"/>
               <a:t>Click to edit Master text styles</a:t>
             </a:r>
           </a:p>
           <a:p>
             <a:pPr lvl="1"/>
             <a:r>
-              <a:rPr lang="en-US" smtClean="0"/>
+              <a:rPr lang="en-US"/>
               <a:t>Second level</a:t>
             </a:r>
           </a:p>
           <a:p>
             <a:pPr lvl="2"/>
             <a:r>
-              <a:rPr lang="en-US" smtClean="0"/>
+              <a:rPr lang="en-US"/>
               <a:t>Third level</a:t>
             </a:r>
           </a:p>
           <a:p>
             <a:pPr lvl="3"/>
             <a:r>
-              <a:rPr lang="en-US" smtClean="0"/>
+              <a:rPr lang="en-US"/>
               <a:t>Fourth level</a:t>
             </a:r>
           </a:p>
           <a:p>
             <a:pPr lvl="4"/>
             <a:r>
-              <a:rPr lang="en-US" smtClean="0"/>
+              <a:rPr lang="en-US"/>
               <a:t>Fifth level</a:t>
             </a:r>
-            <a:endParaRPr lang="en-US"/>
           </a:p>
         </p:txBody>
       </p:sp>
@@ -1355,7 +1359,7 @@
           <a:p>
             <a:fld id="{5BCAD085-E8A6-8845-BD4E-CB4CCA059FC4}" type="datetimeFigureOut">
               <a:rPr lang="en-US" smtClean="0"/>
-              <a:t>1/27/13</a:t>
+              <a:t>4/30/2026</a:t>
             </a:fld>
             <a:endParaRPr lang="en-US"/>
           </a:p>
@@ -1453,10 +1457,9 @@
           </a:lstStyle>
           <a:p>
             <a:r>
-              <a:rPr lang="en-US" smtClean="0"/>
+              <a:rPr lang="en-US"/>
               <a:t>Click to edit Master title style</a:t>
             </a:r>
-            <a:endParaRPr lang="en-US"/>
           </a:p>
         </p:txBody>
       </p:sp>
@@ -1519,7 +1522,7 @@
           <a:p>
             <a:pPr lvl="0"/>
             <a:r>
-              <a:rPr lang="en-US" smtClean="0"/>
+              <a:rPr lang="en-US"/>
               <a:t>Click to edit Master text styles</a:t>
             </a:r>
           </a:p>
@@ -1575,38 +1578,37 @@
           <a:p>
             <a:pPr lvl="0"/>
             <a:r>
-              <a:rPr lang="en-US" smtClean="0"/>
+              <a:rPr lang="en-US"/>
               <a:t>Click to edit Master text styles</a:t>
             </a:r>
           </a:p>
           <a:p>
             <a:pPr lvl="1"/>
             <a:r>
-              <a:rPr lang="en-US" smtClean="0"/>
+              <a:rPr lang="en-US"/>
               <a:t>Second level</a:t>
             </a:r>
           </a:p>
           <a:p>
             <a:pPr lvl="2"/>
             <a:r>
-              <a:rPr lang="en-US" smtClean="0"/>
+              <a:rPr lang="en-US"/>
               <a:t>Third level</a:t>
             </a:r>
           </a:p>
           <a:p>
             <a:pPr lvl="3"/>
             <a:r>
-              <a:rPr lang="en-US" smtClean="0"/>
+              <a:rPr lang="en-US"/>
               <a:t>Fourth level</a:t>
             </a:r>
           </a:p>
           <a:p>
             <a:pPr lvl="4"/>
             <a:r>
-              <a:rPr lang="en-US" smtClean="0"/>
+              <a:rPr lang="en-US"/>
               <a:t>Fifth level</a:t>
             </a:r>
-            <a:endParaRPr lang="en-US"/>
           </a:p>
         </p:txBody>
       </p:sp>
@@ -1669,7 +1671,7 @@
           <a:p>
             <a:pPr lvl="0"/>
             <a:r>
-              <a:rPr lang="en-US" smtClean="0"/>
+              <a:rPr lang="en-US"/>
               <a:t>Click to edit Master text styles</a:t>
             </a:r>
           </a:p>
@@ -1725,38 +1727,37 @@
           <a:p>
             <a:pPr lvl="0"/>
             <a:r>
-              <a:rPr lang="en-US" smtClean="0"/>
+              <a:rPr lang="en-US"/>
               <a:t>Click to edit Master text styles</a:t>
             </a:r>
           </a:p>
           <a:p>
             <a:pPr lvl="1"/>
             <a:r>
-              <a:rPr lang="en-US" smtClean="0"/>
+              <a:rPr lang="en-US"/>
               <a:t>Second level</a:t>
             </a:r>
           </a:p>
           <a:p>
             <a:pPr lvl="2"/>
             <a:r>
-              <a:rPr lang="en-US" smtClean="0"/>
+              <a:rPr lang="en-US"/>
               <a:t>Third level</a:t>
             </a:r>
           </a:p>
           <a:p>
             <a:pPr lvl="3"/>
             <a:r>
-              <a:rPr lang="en-US" smtClean="0"/>
+              <a:rPr lang="en-US"/>
               <a:t>Fourth level</a:t>
             </a:r>
           </a:p>
           <a:p>
             <a:pPr lvl="4"/>
             <a:r>
-              <a:rPr lang="en-US" smtClean="0"/>
+              <a:rPr lang="en-US"/>
               <a:t>Fifth level</a:t>
             </a:r>
-            <a:endParaRPr lang="en-US"/>
           </a:p>
         </p:txBody>
       </p:sp>
@@ -1777,7 +1778,7 @@
           <a:p>
             <a:fld id="{5BCAD085-E8A6-8845-BD4E-CB4CCA059FC4}" type="datetimeFigureOut">
               <a:rPr lang="en-US" smtClean="0"/>
-              <a:t>1/27/13</a:t>
+              <a:t>4/30/2026</a:t>
             </a:fld>
             <a:endParaRPr lang="en-US"/>
           </a:p>
@@ -1871,10 +1872,9 @@
           <a:lstStyle/>
           <a:p>
             <a:r>
-              <a:rPr lang="en-US" smtClean="0"/>
+              <a:rPr lang="en-US"/>
               <a:t>Click to edit Master title style</a:t>
             </a:r>
-            <a:endParaRPr lang="en-US"/>
           </a:p>
         </p:txBody>
       </p:sp>
@@ -1895,7 +1895,7 @@
           <a:p>
             <a:fld id="{5BCAD085-E8A6-8845-BD4E-CB4CCA059FC4}" type="datetimeFigureOut">
               <a:rPr lang="en-US" smtClean="0"/>
-              <a:t>1/27/13</a:t>
+              <a:t>4/30/2026</a:t>
             </a:fld>
             <a:endParaRPr lang="en-US"/>
           </a:p>
@@ -1990,7 +1990,7 @@
           <a:p>
             <a:fld id="{5BCAD085-E8A6-8845-BD4E-CB4CCA059FC4}" type="datetimeFigureOut">
               <a:rPr lang="en-US" smtClean="0"/>
-              <a:t>1/27/13</a:t>
+              <a:t>4/30/2026</a:t>
             </a:fld>
             <a:endParaRPr lang="en-US"/>
           </a:p>
@@ -2093,10 +2093,9 @@
           </a:lstStyle>
           <a:p>
             <a:r>
-              <a:rPr lang="en-US" smtClean="0"/>
+              <a:rPr lang="en-US"/>
               <a:t>Click to edit Master title style</a:t>
             </a:r>
-            <a:endParaRPr lang="en-US"/>
           </a:p>
         </p:txBody>
       </p:sp>
@@ -2150,38 +2149,37 @@
           <a:p>
             <a:pPr lvl="0"/>
             <a:r>
-              <a:rPr lang="en-US" smtClean="0"/>
+              <a:rPr lang="en-US"/>
               <a:t>Click to edit Master text styles</a:t>
             </a:r>
           </a:p>
           <a:p>
             <a:pPr lvl="1"/>
             <a:r>
-              <a:rPr lang="en-US" smtClean="0"/>
+              <a:rPr lang="en-US"/>
               <a:t>Second level</a:t>
             </a:r>
           </a:p>
           <a:p>
             <a:pPr lvl="2"/>
             <a:r>
-              <a:rPr lang="en-US" smtClean="0"/>
+              <a:rPr lang="en-US"/>
               <a:t>Third level</a:t>
             </a:r>
           </a:p>
           <a:p>
             <a:pPr lvl="3"/>
             <a:r>
-              <a:rPr lang="en-US" smtClean="0"/>
+              <a:rPr lang="en-US"/>
               <a:t>Fourth level</a:t>
             </a:r>
           </a:p>
           <a:p>
             <a:pPr lvl="4"/>
             <a:r>
-              <a:rPr lang="en-US" smtClean="0"/>
+              <a:rPr lang="en-US"/>
               <a:t>Fifth level</a:t>
             </a:r>
-            <a:endParaRPr lang="en-US"/>
           </a:p>
         </p:txBody>
       </p:sp>
@@ -2244,7 +2242,7 @@
           <a:p>
             <a:pPr lvl="0"/>
             <a:r>
-              <a:rPr lang="en-US" smtClean="0"/>
+              <a:rPr lang="en-US"/>
               <a:t>Click to edit Master text styles</a:t>
             </a:r>
           </a:p>
@@ -2267,7 +2265,7 @@
           <a:p>
             <a:fld id="{5BCAD085-E8A6-8845-BD4E-CB4CCA059FC4}" type="datetimeFigureOut">
               <a:rPr lang="en-US" smtClean="0"/>
-              <a:t>1/27/13</a:t>
+              <a:t>4/30/2026</a:t>
             </a:fld>
             <a:endParaRPr lang="en-US"/>
           </a:p>
@@ -2370,10 +2368,9 @@
           </a:lstStyle>
           <a:p>
             <a:r>
-              <a:rPr lang="en-US" smtClean="0"/>
+              <a:rPr lang="en-US"/>
               <a:t>Click to edit Master title style</a:t>
             </a:r>
-            <a:endParaRPr lang="en-US"/>
           </a:p>
         </p:txBody>
       </p:sp>
@@ -2497,7 +2494,7 @@
           <a:p>
             <a:pPr lvl="0"/>
             <a:r>
-              <a:rPr lang="en-US" smtClean="0"/>
+              <a:rPr lang="en-US"/>
               <a:t>Click to edit Master text styles</a:t>
             </a:r>
           </a:p>
@@ -2520,7 +2517,7 @@
           <a:p>
             <a:fld id="{5BCAD085-E8A6-8845-BD4E-CB4CCA059FC4}" type="datetimeFigureOut">
               <a:rPr lang="en-US" smtClean="0"/>
-              <a:t>1/27/13</a:t>
+              <a:t>4/30/2026</a:t>
             </a:fld>
             <a:endParaRPr lang="en-US"/>
           </a:p>
@@ -2629,10 +2626,9 @@
           <a:lstStyle/>
           <a:p>
             <a:r>
-              <a:rPr lang="en-US" smtClean="0"/>
+              <a:rPr lang="en-US"/>
               <a:t>Click to edit Master title style</a:t>
             </a:r>
-            <a:endParaRPr lang="en-US"/>
           </a:p>
         </p:txBody>
       </p:sp>
@@ -2663,38 +2659,37 @@
           <a:p>
             <a:pPr lvl="0"/>
             <a:r>
-              <a:rPr lang="en-US" smtClean="0"/>
+              <a:rPr lang="en-US"/>
               <a:t>Click to edit Master text styles</a:t>
             </a:r>
           </a:p>
           <a:p>
             <a:pPr lvl="1"/>
             <a:r>
-              <a:rPr lang="en-US" smtClean="0"/>
+              <a:rPr lang="en-US"/>
               <a:t>Second level</a:t>
             </a:r>
           </a:p>
           <a:p>
             <a:pPr lvl="2"/>
             <a:r>
-              <a:rPr lang="en-US" smtClean="0"/>
+              <a:rPr lang="en-US"/>
               <a:t>Third level</a:t>
             </a:r>
           </a:p>
           <a:p>
             <a:pPr lvl="3"/>
             <a:r>
-              <a:rPr lang="en-US" smtClean="0"/>
+              <a:rPr lang="en-US"/>
               <a:t>Fourth level</a:t>
             </a:r>
           </a:p>
           <a:p>
             <a:pPr lvl="4"/>
             <a:r>
-              <a:rPr lang="en-US" smtClean="0"/>
+              <a:rPr lang="en-US"/>
               <a:t>Fifth level</a:t>
             </a:r>
-            <a:endParaRPr lang="en-US"/>
           </a:p>
         </p:txBody>
       </p:sp>
@@ -2733,7 +2728,7 @@
           <a:p>
             <a:fld id="{5BCAD085-E8A6-8845-BD4E-CB4CCA059FC4}" type="datetimeFigureOut">
               <a:rPr lang="en-US" smtClean="0"/>
-              <a:t>1/27/13</a:t>
+              <a:t>4/30/2026</a:t>
             </a:fld>
             <a:endParaRPr lang="en-US"/>
           </a:p>
@@ -3092,7 +3087,7 @@
 </file>
 
 <file path=ppt/slides/slide1.xml><?xml version="1.0" encoding="utf-8"?>
-<p:sld xmlns:a="http://schemas.openxmlformats.org/drawingml/2006/main" xmlns:p="http://schemas.openxmlformats.org/presentationml/2006/main" xmlns:r="http://schemas.openxmlformats.org/officeDocument/2006/relationships">
+<p:sld xmlns:a="http://schemas.openxmlformats.org/drawingml/2006/main" xmlns:r="http://schemas.openxmlformats.org/officeDocument/2006/relationships" xmlns:p="http://schemas.openxmlformats.org/presentationml/2006/main">
   <p:cSld>
     <p:bg>
       <p:bgPr>
@@ -3108,7 +3103,14 @@
         <p:cNvGrpSpPr/>
         <p:nvPr/>
       </p:nvGrpSpPr>
-      <p:grpSpPr/>
+      <p:grpSpPr>
+        <a:xfrm>
+          <a:off x="0" y="0"/>
+          <a:ext cx="0" cy="0"/>
+          <a:chOff x="0" y="0"/>
+          <a:chExt cx="0" cy="0"/>
+        </a:xfrm>
+      </p:grpSpPr>
       <p:sp>
         <p:nvSpPr>
           <p:cNvPr id="2" name="Rectangle 1"/>
@@ -3151,6 +3153,7 @@
           <a:lstStyle/>
           <a:p>
             <a:pPr algn="ctr"/>
+            <a:endParaRPr/>
           </a:p>
         </p:txBody>
       </p:sp>
@@ -3162,8 +3165,8 @@
         </p:nvSpPr>
         <p:spPr>
           <a:xfrm>
-            <a:off x="914400" y="2286000"/>
-            <a:ext cx="7315200" cy="1828800"/>
+            <a:off x="48005" y="2286000"/>
+            <a:ext cx="9047991" cy="1872307"/>
           </a:xfrm>
           <a:prstGeom prst="rect">
             <a:avLst/>
@@ -3177,7 +3180,7 @@
           <a:lstStyle/>
           <a:p>
             <a:pPr algn="ctr">
-              <a:defRPr b="1" sz="4400">
+              <a:defRPr sz="4400" b="1">
                 <a:solidFill>
                   <a:srgbClr val="322D2D"/>
                 </a:solidFill>
@@ -3185,6 +3188,7 @@
               </a:defRPr>
             </a:pPr>
             <a:r>
+              <a:rPr dirty="0"/>
               <a:t>SMART ALUMNI MENTORING SYSTEM</a:t>
             </a:r>
           </a:p>
@@ -3201,22 +3205,31 @@
               </a:defRPr>
             </a:pPr>
             <a:r>
+              <a:rPr dirty="0"/>
               <a:t>Bridging the Gap Between Students and Industry Experts</a:t>
             </a:r>
           </a:p>
           <a:p>
-            <a:br/>
-            <a:pPr algn="ctr">
-              <a:defRPr sz="1800">
-                <a:solidFill>
-                  <a:srgbClr val="5A5550"/>
-                </a:solidFill>
-                <a:latin typeface="Calibri Light"/>
-              </a:defRPr>
-            </a:pPr>
-            <a:r>
-              <a:t>Presented by: [Your Name]</a:t>
-            </a:r>
+            <a:br>
+              <a:rPr dirty="0"/>
+            </a:br>
+            <a:r>
+              <a:rPr dirty="0"/>
+              <a:t>Presented by: </a:t>
+            </a:r>
+            <a:r>
+              <a:rPr lang="en-US" dirty="0"/>
+              <a:t>L </a:t>
+            </a:r>
+            <a:r>
+              <a:rPr lang="en-US" dirty="0" err="1"/>
+              <a:t>Jithesh</a:t>
+            </a:r>
+            <a:r>
+              <a:rPr lang="en-US" dirty="0"/>
+              <a:t>, Kolli Bharath, Pachikolla Varun Kumar </a:t>
+            </a:r>
+            <a:endParaRPr dirty="0"/>
           </a:p>
         </p:txBody>
       </p:sp>
@@ -3229,7 +3242,7 @@
 </file>
 
 <file path=ppt/slides/slide10.xml><?xml version="1.0" encoding="utf-8"?>
-<p:sld xmlns:a="http://schemas.openxmlformats.org/drawingml/2006/main" xmlns:p="http://schemas.openxmlformats.org/presentationml/2006/main" xmlns:r="http://schemas.openxmlformats.org/officeDocument/2006/relationships">
+<p:sld xmlns:a="http://schemas.openxmlformats.org/drawingml/2006/main" xmlns:r="http://schemas.openxmlformats.org/officeDocument/2006/relationships" xmlns:p="http://schemas.openxmlformats.org/presentationml/2006/main">
   <p:cSld>
     <p:bg>
       <p:bgPr>
@@ -3245,7 +3258,14 @@
         <p:cNvGrpSpPr/>
         <p:nvPr/>
       </p:nvGrpSpPr>
-      <p:grpSpPr/>
+      <p:grpSpPr>
+        <a:xfrm>
+          <a:off x="0" y="0"/>
+          <a:ext cx="0" cy="0"/>
+          <a:chOff x="0" y="0"/>
+          <a:chExt cx="0" cy="0"/>
+        </a:xfrm>
+      </p:grpSpPr>
       <p:sp>
         <p:nvSpPr>
           <p:cNvPr id="2" name="Rectangle 1"/>
@@ -3288,6 +3308,7 @@
           <a:lstStyle/>
           <a:p>
             <a:pPr algn="ctr"/>
+            <a:endParaRPr/>
           </a:p>
         </p:txBody>
       </p:sp>
@@ -3314,7 +3335,7 @@
           <a:lstStyle/>
           <a:p>
             <a:pPr>
-              <a:defRPr b="1" sz="3600">
+              <a:defRPr sz="3600" b="1">
                 <a:solidFill>
                   <a:srgbClr val="322D2D"/>
                 </a:solidFill>
@@ -3369,6 +3390,7 @@
           <a:lstStyle/>
           <a:p>
             <a:pPr algn="ctr"/>
+            <a:endParaRPr/>
           </a:p>
         </p:txBody>
       </p:sp>
@@ -3395,7 +3417,7 @@
           <a:lstStyle/>
           <a:p>
             <a:pPr>
-              <a:defRPr b="1" sz="2000">
+              <a:defRPr sz="2000" b="1">
                 <a:solidFill>
                   <a:srgbClr val="322D2D"/>
                 </a:solidFill>
@@ -3482,6 +3504,7 @@
           <a:lstStyle/>
           <a:p>
             <a:pPr algn="ctr"/>
+            <a:endParaRPr/>
           </a:p>
         </p:txBody>
       </p:sp>
@@ -3508,7 +3531,7 @@
           <a:lstStyle/>
           <a:p>
             <a:pPr>
-              <a:defRPr b="1" sz="2000">
+              <a:defRPr sz="2000" b="1">
                 <a:solidFill>
                   <a:srgbClr val="322D2D"/>
                 </a:solidFill>
@@ -3595,6 +3618,7 @@
           <a:lstStyle/>
           <a:p>
             <a:pPr algn="ctr"/>
+            <a:endParaRPr/>
           </a:p>
         </p:txBody>
       </p:sp>
@@ -3621,7 +3645,7 @@
           <a:lstStyle/>
           <a:p>
             <a:pPr>
-              <a:defRPr b="1" sz="2000">
+              <a:defRPr sz="2000" b="1">
                 <a:solidFill>
                   <a:srgbClr val="322D2D"/>
                 </a:solidFill>
@@ -3675,7 +3699,7 @@
 </file>
 
 <file path=ppt/slides/slide11.xml><?xml version="1.0" encoding="utf-8"?>
-<p:sld xmlns:a="http://schemas.openxmlformats.org/drawingml/2006/main" xmlns:p="http://schemas.openxmlformats.org/presentationml/2006/main" xmlns:r="http://schemas.openxmlformats.org/officeDocument/2006/relationships">
+<p:sld xmlns:a="http://schemas.openxmlformats.org/drawingml/2006/main" xmlns:r="http://schemas.openxmlformats.org/officeDocument/2006/relationships" xmlns:p="http://schemas.openxmlformats.org/presentationml/2006/main">
   <p:cSld>
     <p:bg>
       <p:bgPr>
@@ -3691,7 +3715,14 @@
         <p:cNvGrpSpPr/>
         <p:nvPr/>
       </p:nvGrpSpPr>
-      <p:grpSpPr/>
+      <p:grpSpPr>
+        <a:xfrm>
+          <a:off x="0" y="0"/>
+          <a:ext cx="0" cy="0"/>
+          <a:chOff x="0" y="0"/>
+          <a:chExt cx="0" cy="0"/>
+        </a:xfrm>
+      </p:grpSpPr>
       <p:sp>
         <p:nvSpPr>
           <p:cNvPr id="2" name="Rectangle 1"/>
@@ -3734,6 +3765,7 @@
           <a:lstStyle/>
           <a:p>
             <a:pPr algn="ctr"/>
+            <a:endParaRPr/>
           </a:p>
         </p:txBody>
       </p:sp>
@@ -3760,7 +3792,7 @@
           <a:lstStyle/>
           <a:p>
             <a:pPr>
-              <a:defRPr b="1" sz="3600">
+              <a:defRPr sz="3600" b="1">
                 <a:solidFill>
                   <a:srgbClr val="322D2D"/>
                 </a:solidFill>
@@ -3815,6 +3847,7 @@
           <a:lstStyle/>
           <a:p>
             <a:pPr algn="ctr"/>
+            <a:endParaRPr/>
           </a:p>
         </p:txBody>
       </p:sp>
@@ -3895,6 +3928,7 @@
           <a:lstStyle/>
           <a:p>
             <a:pPr algn="ctr"/>
+            <a:endParaRPr/>
           </a:p>
         </p:txBody>
       </p:sp>
@@ -3975,6 +4009,7 @@
           <a:lstStyle/>
           <a:p>
             <a:pPr algn="ctr"/>
+            <a:endParaRPr/>
           </a:p>
         </p:txBody>
       </p:sp>
@@ -4055,6 +4090,7 @@
           <a:lstStyle/>
           <a:p>
             <a:pPr algn="ctr"/>
+            <a:endParaRPr/>
           </a:p>
         </p:txBody>
       </p:sp>
@@ -4135,6 +4171,7 @@
           <a:lstStyle/>
           <a:p>
             <a:pPr algn="ctr"/>
+            <a:endParaRPr/>
           </a:p>
         </p:txBody>
       </p:sp>
@@ -4215,6 +4252,7 @@
           <a:lstStyle/>
           <a:p>
             <a:pPr algn="ctr"/>
+            <a:endParaRPr/>
           </a:p>
         </p:txBody>
       </p:sp>
@@ -4262,7 +4300,7 @@
 </file>
 
 <file path=ppt/slides/slide12.xml><?xml version="1.0" encoding="utf-8"?>
-<p:sld xmlns:a="http://schemas.openxmlformats.org/drawingml/2006/main" xmlns:p="http://schemas.openxmlformats.org/presentationml/2006/main" xmlns:r="http://schemas.openxmlformats.org/officeDocument/2006/relationships">
+<p:sld xmlns:a="http://schemas.openxmlformats.org/drawingml/2006/main" xmlns:r="http://schemas.openxmlformats.org/officeDocument/2006/relationships" xmlns:p="http://schemas.openxmlformats.org/presentationml/2006/main">
   <p:cSld>
     <p:bg>
       <p:bgPr>
@@ -4278,7 +4316,14 @@
         <p:cNvGrpSpPr/>
         <p:nvPr/>
       </p:nvGrpSpPr>
-      <p:grpSpPr/>
+      <p:grpSpPr>
+        <a:xfrm>
+          <a:off x="0" y="0"/>
+          <a:ext cx="0" cy="0"/>
+          <a:chOff x="0" y="0"/>
+          <a:chExt cx="0" cy="0"/>
+        </a:xfrm>
+      </p:grpSpPr>
       <p:sp>
         <p:nvSpPr>
           <p:cNvPr id="2" name="Rectangle 1"/>
@@ -4321,6 +4366,7 @@
           <a:lstStyle/>
           <a:p>
             <a:pPr algn="ctr"/>
+            <a:endParaRPr/>
           </a:p>
         </p:txBody>
       </p:sp>
@@ -4347,7 +4393,7 @@
           <a:lstStyle/>
           <a:p>
             <a:pPr>
-              <a:defRPr b="1" sz="3600">
+              <a:defRPr sz="3600" b="1">
                 <a:solidFill>
                   <a:srgbClr val="322D2D"/>
                 </a:solidFill>
@@ -4402,6 +4448,7 @@
           <a:lstStyle/>
           <a:p>
             <a:pPr algn="ctr"/>
+            <a:endParaRPr/>
           </a:p>
         </p:txBody>
       </p:sp>
@@ -4428,7 +4475,7 @@
           <a:lstStyle/>
           <a:p>
             <a:pPr>
-              <a:defRPr b="1" sz="2000">
+              <a:defRPr sz="2000" b="1">
                 <a:solidFill>
                   <a:srgbClr val="322D2D"/>
                 </a:solidFill>
@@ -4515,6 +4562,7 @@
           <a:lstStyle/>
           <a:p>
             <a:pPr algn="ctr"/>
+            <a:endParaRPr/>
           </a:p>
         </p:txBody>
       </p:sp>
@@ -4541,7 +4589,7 @@
           <a:lstStyle/>
           <a:p>
             <a:pPr>
-              <a:defRPr b="1" sz="2000">
+              <a:defRPr sz="2000" b="1">
                 <a:solidFill>
                   <a:srgbClr val="322D2D"/>
                 </a:solidFill>
@@ -4595,7 +4643,7 @@
 </file>
 
 <file path=ppt/slides/slide13.xml><?xml version="1.0" encoding="utf-8"?>
-<p:sld xmlns:a="http://schemas.openxmlformats.org/drawingml/2006/main" xmlns:p="http://schemas.openxmlformats.org/presentationml/2006/main" xmlns:r="http://schemas.openxmlformats.org/officeDocument/2006/relationships">
+<p:sld xmlns:a="http://schemas.openxmlformats.org/drawingml/2006/main" xmlns:r="http://schemas.openxmlformats.org/officeDocument/2006/relationships" xmlns:p="http://schemas.openxmlformats.org/presentationml/2006/main">
   <p:cSld>
     <p:bg>
       <p:bgPr>
@@ -4611,7 +4659,14 @@
         <p:cNvGrpSpPr/>
         <p:nvPr/>
       </p:nvGrpSpPr>
-      <p:grpSpPr/>
+      <p:grpSpPr>
+        <a:xfrm>
+          <a:off x="0" y="0"/>
+          <a:ext cx="0" cy="0"/>
+          <a:chOff x="0" y="0"/>
+          <a:chExt cx="0" cy="0"/>
+        </a:xfrm>
+      </p:grpSpPr>
       <p:sp>
         <p:nvSpPr>
           <p:cNvPr id="2" name="Rectangle 1"/>
@@ -4654,6 +4709,7 @@
           <a:lstStyle/>
           <a:p>
             <a:pPr algn="ctr"/>
+            <a:endParaRPr/>
           </a:p>
         </p:txBody>
       </p:sp>
@@ -4680,7 +4736,7 @@
           <a:lstStyle/>
           <a:p>
             <a:pPr>
-              <a:defRPr b="1" sz="3600">
+              <a:defRPr sz="3600" b="1">
                 <a:solidFill>
                   <a:srgbClr val="322D2D"/>
                 </a:solidFill>
@@ -4716,7 +4772,7 @@
           <a:lstStyle/>
           <a:p>
             <a:pPr>
-              <a:defRPr b="0" sz="2400">
+              <a:defRPr sz="2400" b="0">
                 <a:solidFill>
                   <a:srgbClr val="322D2D"/>
                 </a:solidFill>
@@ -4802,7 +4858,7 @@
 </file>
 
 <file path=ppt/slides/slide14.xml><?xml version="1.0" encoding="utf-8"?>
-<p:sld xmlns:a="http://schemas.openxmlformats.org/drawingml/2006/main" xmlns:p="http://schemas.openxmlformats.org/presentationml/2006/main" xmlns:r="http://schemas.openxmlformats.org/officeDocument/2006/relationships">
+<p:sld xmlns:a="http://schemas.openxmlformats.org/drawingml/2006/main" xmlns:r="http://schemas.openxmlformats.org/officeDocument/2006/relationships" xmlns:p="http://schemas.openxmlformats.org/presentationml/2006/main">
   <p:cSld>
     <p:bg>
       <p:bgPr>
@@ -4818,7 +4874,14 @@
         <p:cNvGrpSpPr/>
         <p:nvPr/>
       </p:nvGrpSpPr>
-      <p:grpSpPr/>
+      <p:grpSpPr>
+        <a:xfrm>
+          <a:off x="0" y="0"/>
+          <a:ext cx="0" cy="0"/>
+          <a:chOff x="0" y="0"/>
+          <a:chExt cx="0" cy="0"/>
+        </a:xfrm>
+      </p:grpSpPr>
       <p:sp>
         <p:nvSpPr>
           <p:cNvPr id="2" name="Rectangle 1"/>
@@ -4861,6 +4924,7 @@
           <a:lstStyle/>
           <a:p>
             <a:pPr algn="ctr"/>
+            <a:endParaRPr/>
           </a:p>
         </p:txBody>
       </p:sp>
@@ -4887,7 +4951,7 @@
           <a:lstStyle/>
           <a:p>
             <a:pPr>
-              <a:defRPr b="1" sz="3600">
+              <a:defRPr sz="3600" b="1">
                 <a:solidFill>
                   <a:srgbClr val="322D2D"/>
                 </a:solidFill>
@@ -4923,7 +4987,7 @@
           <a:lstStyle/>
           <a:p>
             <a:pPr>
-              <a:defRPr b="1" sz="2800">
+              <a:defRPr sz="2800" b="1">
                 <a:solidFill>
                   <a:srgbClr val="322D2D"/>
                 </a:solidFill>
@@ -4993,7 +5057,7 @@
 </file>
 
 <file path=ppt/slides/slide2.xml><?xml version="1.0" encoding="utf-8"?>
-<p:sld xmlns:a="http://schemas.openxmlformats.org/drawingml/2006/main" xmlns:p="http://schemas.openxmlformats.org/presentationml/2006/main" xmlns:r="http://schemas.openxmlformats.org/officeDocument/2006/relationships">
+<p:sld xmlns:a="http://schemas.openxmlformats.org/drawingml/2006/main" xmlns:r="http://schemas.openxmlformats.org/officeDocument/2006/relationships" xmlns:p="http://schemas.openxmlformats.org/presentationml/2006/main">
   <p:cSld>
     <p:bg>
       <p:bgPr>
@@ -5009,7 +5073,14 @@
         <p:cNvGrpSpPr/>
         <p:nvPr/>
       </p:nvGrpSpPr>
-      <p:grpSpPr/>
+      <p:grpSpPr>
+        <a:xfrm>
+          <a:off x="0" y="0"/>
+          <a:ext cx="0" cy="0"/>
+          <a:chOff x="0" y="0"/>
+          <a:chExt cx="0" cy="0"/>
+        </a:xfrm>
+      </p:grpSpPr>
       <p:sp>
         <p:nvSpPr>
           <p:cNvPr id="2" name="Rectangle 1"/>
@@ -5052,6 +5123,7 @@
           <a:lstStyle/>
           <a:p>
             <a:pPr algn="ctr"/>
+            <a:endParaRPr/>
           </a:p>
         </p:txBody>
       </p:sp>
@@ -5078,7 +5150,7 @@
           <a:lstStyle/>
           <a:p>
             <a:pPr>
-              <a:defRPr b="1" sz="3600">
+              <a:defRPr sz="3600" b="1">
                 <a:solidFill>
                   <a:srgbClr val="322D2D"/>
                 </a:solidFill>
@@ -5133,6 +5205,7 @@
           <a:lstStyle/>
           <a:p>
             <a:pPr algn="ctr"/>
+            <a:endParaRPr/>
           </a:p>
         </p:txBody>
       </p:sp>
@@ -5159,7 +5232,7 @@
           <a:lstStyle/>
           <a:p>
             <a:pPr>
-              <a:defRPr b="1" sz="2000">
+              <a:defRPr sz="2000" b="1">
                 <a:solidFill>
                   <a:srgbClr val="322D2D"/>
                 </a:solidFill>
@@ -5262,6 +5335,7 @@
           <a:lstStyle/>
           <a:p>
             <a:pPr algn="ctr"/>
+            <a:endParaRPr/>
           </a:p>
         </p:txBody>
       </p:sp>
@@ -5288,7 +5362,7 @@
           <a:lstStyle/>
           <a:p>
             <a:pPr>
-              <a:defRPr b="1" sz="2000">
+              <a:defRPr sz="2000" b="1">
                 <a:solidFill>
                   <a:srgbClr val="322D2D"/>
                 </a:solidFill>
@@ -5358,7 +5432,7 @@
 </file>
 
 <file path=ppt/slides/slide3.xml><?xml version="1.0" encoding="utf-8"?>
-<p:sld xmlns:a="http://schemas.openxmlformats.org/drawingml/2006/main" xmlns:p="http://schemas.openxmlformats.org/presentationml/2006/main" xmlns:r="http://schemas.openxmlformats.org/officeDocument/2006/relationships">
+<p:sld xmlns:a="http://schemas.openxmlformats.org/drawingml/2006/main" xmlns:r="http://schemas.openxmlformats.org/officeDocument/2006/relationships" xmlns:p="http://schemas.openxmlformats.org/presentationml/2006/main">
   <p:cSld>
     <p:bg>
       <p:bgPr>
@@ -5374,7 +5448,14 @@
         <p:cNvGrpSpPr/>
         <p:nvPr/>
       </p:nvGrpSpPr>
-      <p:grpSpPr/>
+      <p:grpSpPr>
+        <a:xfrm>
+          <a:off x="0" y="0"/>
+          <a:ext cx="0" cy="0"/>
+          <a:chOff x="0" y="0"/>
+          <a:chExt cx="0" cy="0"/>
+        </a:xfrm>
+      </p:grpSpPr>
       <p:sp>
         <p:nvSpPr>
           <p:cNvPr id="2" name="Rectangle 1"/>
@@ -5417,6 +5498,7 @@
           <a:lstStyle/>
           <a:p>
             <a:pPr algn="ctr"/>
+            <a:endParaRPr/>
           </a:p>
         </p:txBody>
       </p:sp>
@@ -5443,7 +5525,7 @@
           <a:lstStyle/>
           <a:p>
             <a:pPr>
-              <a:defRPr b="1" sz="3600">
+              <a:defRPr sz="3600" b="1">
                 <a:solidFill>
                   <a:srgbClr val="322D2D"/>
                 </a:solidFill>
@@ -5498,6 +5580,7 @@
           <a:lstStyle/>
           <a:p>
             <a:pPr algn="ctr"/>
+            <a:endParaRPr/>
           </a:p>
         </p:txBody>
       </p:sp>
@@ -5524,7 +5607,7 @@
           <a:lstStyle/>
           <a:p>
             <a:pPr>
-              <a:defRPr b="1" sz="2000">
+              <a:defRPr sz="2000" b="1">
                 <a:solidFill>
                   <a:srgbClr val="322D2D"/>
                 </a:solidFill>
@@ -5627,6 +5710,7 @@
           <a:lstStyle/>
           <a:p>
             <a:pPr algn="ctr"/>
+            <a:endParaRPr/>
           </a:p>
         </p:txBody>
       </p:sp>
@@ -5653,7 +5737,7 @@
           <a:lstStyle/>
           <a:p>
             <a:pPr>
-              <a:defRPr b="1" sz="2000">
+              <a:defRPr sz="2000" b="1">
                 <a:solidFill>
                   <a:srgbClr val="322D2D"/>
                 </a:solidFill>
@@ -5756,6 +5840,7 @@
           <a:lstStyle/>
           <a:p>
             <a:pPr algn="ctr"/>
+            <a:endParaRPr/>
           </a:p>
         </p:txBody>
       </p:sp>
@@ -5782,7 +5867,7 @@
           <a:lstStyle/>
           <a:p>
             <a:pPr>
-              <a:defRPr b="1" sz="2000">
+              <a:defRPr sz="2000" b="1">
                 <a:solidFill>
                   <a:srgbClr val="322D2D"/>
                 </a:solidFill>
@@ -5852,7 +5937,7 @@
 </file>
 
 <file path=ppt/slides/slide4.xml><?xml version="1.0" encoding="utf-8"?>
-<p:sld xmlns:a="http://schemas.openxmlformats.org/drawingml/2006/main" xmlns:p="http://schemas.openxmlformats.org/presentationml/2006/main" xmlns:r="http://schemas.openxmlformats.org/officeDocument/2006/relationships">
+<p:sld xmlns:a="http://schemas.openxmlformats.org/drawingml/2006/main" xmlns:r="http://schemas.openxmlformats.org/officeDocument/2006/relationships" xmlns:p="http://schemas.openxmlformats.org/presentationml/2006/main">
   <p:cSld>
     <p:bg>
       <p:bgPr>
@@ -5868,7 +5953,14 @@
         <p:cNvGrpSpPr/>
         <p:nvPr/>
       </p:nvGrpSpPr>
-      <p:grpSpPr/>
+      <p:grpSpPr>
+        <a:xfrm>
+          <a:off x="0" y="0"/>
+          <a:ext cx="0" cy="0"/>
+          <a:chOff x="0" y="0"/>
+          <a:chExt cx="0" cy="0"/>
+        </a:xfrm>
+      </p:grpSpPr>
       <p:sp>
         <p:nvSpPr>
           <p:cNvPr id="2" name="Rectangle 1"/>
@@ -5911,6 +6003,7 @@
           <a:lstStyle/>
           <a:p>
             <a:pPr algn="ctr"/>
+            <a:endParaRPr/>
           </a:p>
         </p:txBody>
       </p:sp>
@@ -5937,7 +6030,7 @@
           <a:lstStyle/>
           <a:p>
             <a:pPr>
-              <a:defRPr b="1" sz="3600">
+              <a:defRPr sz="3600" b="1">
                 <a:solidFill>
                   <a:srgbClr val="322D2D"/>
                 </a:solidFill>
@@ -5992,6 +6085,7 @@
           <a:lstStyle/>
           <a:p>
             <a:pPr algn="ctr"/>
+            <a:endParaRPr/>
           </a:p>
         </p:txBody>
       </p:sp>
@@ -6018,7 +6112,7 @@
           <a:lstStyle/>
           <a:p>
             <a:pPr>
-              <a:defRPr b="1" sz="2000">
+              <a:defRPr sz="2000" b="1">
                 <a:solidFill>
                   <a:srgbClr val="322D2D"/>
                 </a:solidFill>
@@ -6121,6 +6215,7 @@
           <a:lstStyle/>
           <a:p>
             <a:pPr algn="ctr"/>
+            <a:endParaRPr/>
           </a:p>
         </p:txBody>
       </p:sp>
@@ -6147,7 +6242,7 @@
           <a:lstStyle/>
           <a:p>
             <a:pPr>
-              <a:defRPr b="1" sz="2000">
+              <a:defRPr sz="2000" b="1">
                 <a:solidFill>
                   <a:srgbClr val="322D2D"/>
                 </a:solidFill>
@@ -6155,6 +6250,7 @@
               </a:defRPr>
             </a:pPr>
             <a:r>
+              <a:rPr dirty="0"/>
               <a:t>Backend</a:t>
             </a:r>
           </a:p>
@@ -6171,6 +6267,7 @@
               </a:defRPr>
             </a:pPr>
             <a:r>
+              <a:rPr dirty="0"/>
               <a:t>• Node.js</a:t>
             </a:r>
           </a:p>
@@ -6187,6 +6284,7 @@
               </a:defRPr>
             </a:pPr>
             <a:r>
+              <a:rPr dirty="0"/>
               <a:t>• Express Framework</a:t>
             </a:r>
           </a:p>
@@ -6203,6 +6301,7 @@
               </a:defRPr>
             </a:pPr>
             <a:r>
+              <a:rPr dirty="0"/>
               <a:t>• RESTful APIs</a:t>
             </a:r>
           </a:p>
@@ -6250,6 +6349,7 @@
           <a:lstStyle/>
           <a:p>
             <a:pPr algn="ctr"/>
+            <a:endParaRPr/>
           </a:p>
         </p:txBody>
       </p:sp>
@@ -6276,7 +6376,7 @@
           <a:lstStyle/>
           <a:p>
             <a:pPr>
-              <a:defRPr b="1" sz="2000">
+              <a:defRPr sz="2000" b="1">
                 <a:solidFill>
                   <a:srgbClr val="322D2D"/>
                 </a:solidFill>
@@ -6346,7 +6446,7 @@
 </file>
 
 <file path=ppt/slides/slide5.xml><?xml version="1.0" encoding="utf-8"?>
-<p:sld xmlns:a="http://schemas.openxmlformats.org/drawingml/2006/main" xmlns:p="http://schemas.openxmlformats.org/presentationml/2006/main" xmlns:r="http://schemas.openxmlformats.org/officeDocument/2006/relationships">
+<p:sld xmlns:a="http://schemas.openxmlformats.org/drawingml/2006/main" xmlns:r="http://schemas.openxmlformats.org/officeDocument/2006/relationships" xmlns:p="http://schemas.openxmlformats.org/presentationml/2006/main">
   <p:cSld>
     <p:bg>
       <p:bgPr>
@@ -6362,7 +6462,14 @@
         <p:cNvGrpSpPr/>
         <p:nvPr/>
       </p:nvGrpSpPr>
-      <p:grpSpPr/>
+      <p:grpSpPr>
+        <a:xfrm>
+          <a:off x="0" y="0"/>
+          <a:ext cx="0" cy="0"/>
+          <a:chOff x="0" y="0"/>
+          <a:chExt cx="0" cy="0"/>
+        </a:xfrm>
+      </p:grpSpPr>
       <p:sp>
         <p:nvSpPr>
           <p:cNvPr id="2" name="Rectangle 1"/>
@@ -6405,6 +6512,7 @@
           <a:lstStyle/>
           <a:p>
             <a:pPr algn="ctr"/>
+            <a:endParaRPr/>
           </a:p>
         </p:txBody>
       </p:sp>
@@ -6431,7 +6539,7 @@
           <a:lstStyle/>
           <a:p>
             <a:pPr>
-              <a:defRPr b="1" sz="3600">
+              <a:defRPr sz="3600" b="1">
                 <a:solidFill>
                   <a:srgbClr val="322D2D"/>
                 </a:solidFill>
@@ -6467,7 +6575,7 @@
           <a:lstStyle/>
           <a:p>
             <a:pPr>
-              <a:defRPr b="1" sz="2400">
+              <a:defRPr sz="2400" b="1">
                 <a:solidFill>
                   <a:srgbClr val="322D2D"/>
                 </a:solidFill>
@@ -6553,7 +6661,7 @@
 </file>
 
 <file path=ppt/slides/slide6.xml><?xml version="1.0" encoding="utf-8"?>
-<p:sld xmlns:a="http://schemas.openxmlformats.org/drawingml/2006/main" xmlns:p="http://schemas.openxmlformats.org/presentationml/2006/main" xmlns:r="http://schemas.openxmlformats.org/officeDocument/2006/relationships">
+<p:sld xmlns:a="http://schemas.openxmlformats.org/drawingml/2006/main" xmlns:r="http://schemas.openxmlformats.org/officeDocument/2006/relationships" xmlns:p="http://schemas.openxmlformats.org/presentationml/2006/main">
   <p:cSld>
     <p:bg>
       <p:bgPr>
@@ -6569,7 +6677,14 @@
         <p:cNvGrpSpPr/>
         <p:nvPr/>
       </p:nvGrpSpPr>
-      <p:grpSpPr/>
+      <p:grpSpPr>
+        <a:xfrm>
+          <a:off x="0" y="0"/>
+          <a:ext cx="0" cy="0"/>
+          <a:chOff x="0" y="0"/>
+          <a:chExt cx="0" cy="0"/>
+        </a:xfrm>
+      </p:grpSpPr>
       <p:sp>
         <p:nvSpPr>
           <p:cNvPr id="2" name="Rectangle 1"/>
@@ -6612,6 +6727,7 @@
           <a:lstStyle/>
           <a:p>
             <a:pPr algn="ctr"/>
+            <a:endParaRPr/>
           </a:p>
         </p:txBody>
       </p:sp>
@@ -6638,7 +6754,7 @@
           <a:lstStyle/>
           <a:p>
             <a:pPr>
-              <a:defRPr b="1" sz="3600">
+              <a:defRPr sz="3600" b="1">
                 <a:solidFill>
                   <a:srgbClr val="322D2D"/>
                 </a:solidFill>
@@ -6693,6 +6809,7 @@
           <a:lstStyle/>
           <a:p>
             <a:pPr algn="ctr"/>
+            <a:endParaRPr/>
           </a:p>
         </p:txBody>
       </p:sp>
@@ -6719,7 +6836,7 @@
           <a:lstStyle/>
           <a:p>
             <a:pPr>
-              <a:defRPr b="1" sz="2000">
+              <a:defRPr sz="2000" b="1">
                 <a:solidFill>
                   <a:srgbClr val="322D2D"/>
                 </a:solidFill>
@@ -6790,6 +6907,7 @@
           <a:lstStyle/>
           <a:p>
             <a:pPr algn="ctr"/>
+            <a:endParaRPr/>
           </a:p>
         </p:txBody>
       </p:sp>
@@ -6816,7 +6934,7 @@
           <a:lstStyle/>
           <a:p>
             <a:pPr>
-              <a:defRPr b="1" sz="2000">
+              <a:defRPr sz="2000" b="1">
                 <a:solidFill>
                   <a:srgbClr val="322D2D"/>
                 </a:solidFill>
@@ -6887,6 +7005,7 @@
           <a:lstStyle/>
           <a:p>
             <a:pPr algn="ctr"/>
+            <a:endParaRPr/>
           </a:p>
         </p:txBody>
       </p:sp>
@@ -6913,7 +7032,7 @@
           <a:lstStyle/>
           <a:p>
             <a:pPr>
-              <a:defRPr b="1" sz="2000">
+              <a:defRPr sz="2000" b="1">
                 <a:solidFill>
                   <a:srgbClr val="322D2D"/>
                 </a:solidFill>
@@ -6984,6 +7103,7 @@
           <a:lstStyle/>
           <a:p>
             <a:pPr algn="ctr"/>
+            <a:endParaRPr/>
           </a:p>
         </p:txBody>
       </p:sp>
@@ -7010,7 +7130,7 @@
           <a:lstStyle/>
           <a:p>
             <a:pPr>
-              <a:defRPr b="1" sz="2000">
+              <a:defRPr sz="2000" b="1">
                 <a:solidFill>
                   <a:srgbClr val="322D2D"/>
                 </a:solidFill>
@@ -7048,7 +7168,7 @@
 </file>
 
 <file path=ppt/slides/slide7.xml><?xml version="1.0" encoding="utf-8"?>
-<p:sld xmlns:a="http://schemas.openxmlformats.org/drawingml/2006/main" xmlns:p="http://schemas.openxmlformats.org/presentationml/2006/main" xmlns:r="http://schemas.openxmlformats.org/officeDocument/2006/relationships">
+<p:sld xmlns:a="http://schemas.openxmlformats.org/drawingml/2006/main" xmlns:r="http://schemas.openxmlformats.org/officeDocument/2006/relationships" xmlns:p="http://schemas.openxmlformats.org/presentationml/2006/main">
   <p:cSld>
     <p:bg>
       <p:bgPr>
@@ -7064,7 +7184,14 @@
         <p:cNvGrpSpPr/>
         <p:nvPr/>
       </p:nvGrpSpPr>
-      <p:grpSpPr/>
+      <p:grpSpPr>
+        <a:xfrm>
+          <a:off x="0" y="0"/>
+          <a:ext cx="0" cy="0"/>
+          <a:chOff x="0" y="0"/>
+          <a:chExt cx="0" cy="0"/>
+        </a:xfrm>
+      </p:grpSpPr>
       <p:sp>
         <p:nvSpPr>
           <p:cNvPr id="2" name="Rectangle 1"/>
@@ -7107,6 +7234,7 @@
           <a:lstStyle/>
           <a:p>
             <a:pPr algn="ctr"/>
+            <a:endParaRPr/>
           </a:p>
         </p:txBody>
       </p:sp>
@@ -7133,7 +7261,7 @@
           <a:lstStyle/>
           <a:p>
             <a:pPr>
-              <a:defRPr b="1" sz="3600">
+              <a:defRPr sz="3600" b="1">
                 <a:solidFill>
                   <a:srgbClr val="322D2D"/>
                 </a:solidFill>
@@ -7188,6 +7316,7 @@
           <a:lstStyle/>
           <a:p>
             <a:pPr algn="ctr"/>
+            <a:endParaRPr/>
           </a:p>
         </p:txBody>
       </p:sp>
@@ -7214,7 +7343,7 @@
           <a:lstStyle/>
           <a:p>
             <a:pPr>
-              <a:defRPr b="1" sz="2000">
+              <a:defRPr sz="2000" b="1">
                 <a:solidFill>
                   <a:srgbClr val="322D2D"/>
                 </a:solidFill>
@@ -7301,6 +7430,7 @@
           <a:lstStyle/>
           <a:p>
             <a:pPr algn="ctr"/>
+            <a:endParaRPr/>
           </a:p>
         </p:txBody>
       </p:sp>
@@ -7327,7 +7457,7 @@
           <a:lstStyle/>
           <a:p>
             <a:pPr>
-              <a:defRPr b="1" sz="2000">
+              <a:defRPr sz="2000" b="1">
                 <a:solidFill>
                   <a:srgbClr val="322D2D"/>
                 </a:solidFill>
@@ -7381,7 +7511,7 @@
 </file>
 
 <file path=ppt/slides/slide8.xml><?xml version="1.0" encoding="utf-8"?>
-<p:sld xmlns:a="http://schemas.openxmlformats.org/drawingml/2006/main" xmlns:p="http://schemas.openxmlformats.org/presentationml/2006/main" xmlns:r="http://schemas.openxmlformats.org/officeDocument/2006/relationships">
+<p:sld xmlns:a="http://schemas.openxmlformats.org/drawingml/2006/main" xmlns:r="http://schemas.openxmlformats.org/officeDocument/2006/relationships" xmlns:p="http://schemas.openxmlformats.org/presentationml/2006/main">
   <p:cSld>
     <p:bg>
       <p:bgPr>
@@ -7397,7 +7527,14 @@
         <p:cNvGrpSpPr/>
         <p:nvPr/>
       </p:nvGrpSpPr>
-      <p:grpSpPr/>
+      <p:grpSpPr>
+        <a:xfrm>
+          <a:off x="0" y="0"/>
+          <a:ext cx="0" cy="0"/>
+          <a:chOff x="0" y="0"/>
+          <a:chExt cx="0" cy="0"/>
+        </a:xfrm>
+      </p:grpSpPr>
       <p:sp>
         <p:nvSpPr>
           <p:cNvPr id="2" name="Rectangle 1"/>
@@ -7440,6 +7577,7 @@
           <a:lstStyle/>
           <a:p>
             <a:pPr algn="ctr"/>
+            <a:endParaRPr/>
           </a:p>
         </p:txBody>
       </p:sp>
@@ -7466,7 +7604,7 @@
           <a:lstStyle/>
           <a:p>
             <a:pPr>
-              <a:defRPr b="1" sz="3600">
+              <a:defRPr sz="3600" b="1">
                 <a:solidFill>
                   <a:srgbClr val="322D2D"/>
                 </a:solidFill>
@@ -7502,7 +7640,7 @@
           <a:lstStyle/>
           <a:p>
             <a:pPr>
-              <a:defRPr b="0" sz="2400">
+              <a:defRPr sz="2400" b="0">
                 <a:solidFill>
                   <a:srgbClr val="322D2D"/>
                 </a:solidFill>
@@ -7588,7 +7726,7 @@
 </file>
 
 <file path=ppt/slides/slide9.xml><?xml version="1.0" encoding="utf-8"?>
-<p:sld xmlns:a="http://schemas.openxmlformats.org/drawingml/2006/main" xmlns:p="http://schemas.openxmlformats.org/presentationml/2006/main" xmlns:r="http://schemas.openxmlformats.org/officeDocument/2006/relationships">
+<p:sld xmlns:a="http://schemas.openxmlformats.org/drawingml/2006/main" xmlns:r="http://schemas.openxmlformats.org/officeDocument/2006/relationships" xmlns:p="http://schemas.openxmlformats.org/presentationml/2006/main">
   <p:cSld>
     <p:bg>
       <p:bgPr>
@@ -7604,7 +7742,14 @@
         <p:cNvGrpSpPr/>
         <p:nvPr/>
       </p:nvGrpSpPr>
-      <p:grpSpPr/>
+      <p:grpSpPr>
+        <a:xfrm>
+          <a:off x="0" y="0"/>
+          <a:ext cx="0" cy="0"/>
+          <a:chOff x="0" y="0"/>
+          <a:chExt cx="0" cy="0"/>
+        </a:xfrm>
+      </p:grpSpPr>
       <p:sp>
         <p:nvSpPr>
           <p:cNvPr id="2" name="Rectangle 1"/>
@@ -7647,6 +7792,7 @@
           <a:lstStyle/>
           <a:p>
             <a:pPr algn="ctr"/>
+            <a:endParaRPr/>
           </a:p>
         </p:txBody>
       </p:sp>
@@ -7673,7 +7819,7 @@
           <a:lstStyle/>
           <a:p>
             <a:pPr>
-              <a:defRPr b="1" sz="3600">
+              <a:defRPr sz="3600" b="1">
                 <a:solidFill>
                   <a:srgbClr val="322D2D"/>
                 </a:solidFill>
@@ -7728,6 +7874,7 @@
           <a:lstStyle/>
           <a:p>
             <a:pPr algn="ctr"/>
+            <a:endParaRPr/>
           </a:p>
         </p:txBody>
       </p:sp>
@@ -7808,6 +7955,7 @@
           <a:lstStyle/>
           <a:p>
             <a:pPr algn="ctr"/>
+            <a:endParaRPr/>
           </a:p>
         </p:txBody>
       </p:sp>
@@ -7888,6 +8036,7 @@
           <a:lstStyle/>
           <a:p>
             <a:pPr algn="ctr"/>
+            <a:endParaRPr/>
           </a:p>
         </p:txBody>
       </p:sp>
@@ -7968,6 +8117,7 @@
           <a:lstStyle/>
           <a:p>
             <a:pPr algn="ctr"/>
+            <a:endParaRPr/>
           </a:p>
         </p:txBody>
       </p:sp>
@@ -8048,6 +8198,7 @@
           <a:lstStyle/>
           <a:p>
             <a:pPr algn="ctr"/>
+            <a:endParaRPr/>
           </a:p>
         </p:txBody>
       </p:sp>
@@ -8128,6 +8279,7 @@
           <a:lstStyle/>
           <a:p>
             <a:pPr algn="ctr"/>
+            <a:endParaRPr/>
           </a:p>
         </p:txBody>
       </p:sp>

</xml_diff>